<commit_message>
Add remaining AQI project files
</commit_message>
<xml_diff>
--- a/Houston AQI Project PPT.pptx
+++ b/Houston AQI Project PPT.pptx
@@ -5634,7 +5634,7 @@
           <a:bodyPr wrap="square" lIns="0" tIns="0" rIns="0" bIns="0" rtlCol="0" anchor="ctr"/>
           <a:lstStyle/>
           <a:p>
-            <a:pPr marL="0" indent="0">
+            <a:pPr marL="0" indent="0" algn="ctr">
               <a:buNone/>
             </a:pPr>
             <a:r>
@@ -5645,6 +5645,7 @@
                 <a:latin typeface="Georgia" pitchFamily="34" charset="0"/>
                 <a:ea typeface="Georgia" pitchFamily="34" charset="-122"/>
                 <a:cs typeface="Georgia" pitchFamily="34" charset="-120"/>
+                <a:hlinkClick r:id="rId3"/>
               </a:rPr>
               <a:t>Interactive </a:t>
             </a:r>
@@ -5656,6 +5657,7 @@
                 <a:latin typeface="Georgia" pitchFamily="34" charset="0"/>
                 <a:ea typeface="Georgia" pitchFamily="34" charset="-122"/>
                 <a:cs typeface="Georgia" pitchFamily="34" charset="-120"/>
+                <a:hlinkClick r:id="rId3"/>
               </a:rPr>
               <a:t>Streamlit</a:t>
             </a:r>
@@ -5667,6 +5669,7 @@
                 <a:latin typeface="Georgia" pitchFamily="34" charset="0"/>
                 <a:ea typeface="Georgia" pitchFamily="34" charset="-122"/>
                 <a:cs typeface="Georgia" pitchFamily="34" charset="-120"/>
+                <a:hlinkClick r:id="rId3"/>
               </a:rPr>
               <a:t> Dashboard</a:t>
             </a:r>
@@ -5807,7 +5810,7 @@
           <p:nvPr/>
         </p:nvPicPr>
         <p:blipFill>
-          <a:blip r:embed="rId3"/>
+          <a:blip r:embed="rId4"/>
           <a:stretch>
             <a:fillRect/>
           </a:stretch>

</xml_diff>